<commit_message>
cambios del dia 19042021 por la mañana
</commit_message>
<xml_diff>
--- a/INSPECCION_MATERIAL/INSPECCION_PIEL/Docs/QA_INSPECCION_PIEL.pptx
+++ b/INSPECCION_MATERIAL/INSPECCION_PIEL/Docs/QA_INSPECCION_PIEL.pptx
@@ -5,13 +5,16 @@
     <p:sldMasterId id="2147483648" r:id="rId1"/>
   </p:sldMasterIdLst>
   <p:notesMasterIdLst>
-    <p:notesMasterId r:id="rId6"/>
+    <p:notesMasterId r:id="rId9"/>
   </p:notesMasterIdLst>
   <p:sldIdLst>
     <p:sldId id="397" r:id="rId2"/>
-    <p:sldId id="419" r:id="rId3"/>
-    <p:sldId id="420" r:id="rId4"/>
-    <p:sldId id="421" r:id="rId5"/>
+    <p:sldId id="429" r:id="rId3"/>
+    <p:sldId id="431" r:id="rId4"/>
+    <p:sldId id="430" r:id="rId5"/>
+    <p:sldId id="419" r:id="rId6"/>
+    <p:sldId id="420" r:id="rId7"/>
+    <p:sldId id="421" r:id="rId8"/>
   </p:sldIdLst>
   <p:sldSz cx="9144000" cy="6858000" type="screen4x3"/>
   <p:notesSz cx="6858000" cy="9144000"/>
@@ -211,7 +214,7 @@
           <a:p>
             <a:fld id="{A17B1792-3256-4E77-8442-3E205CD69EF5}" type="datetimeFigureOut">
               <a:rPr lang="en-US" smtClean="0"/>
-              <a:t>3/26/2021</a:t>
+              <a:t>4/12/2021</a:t>
             </a:fld>
             <a:endParaRPr lang="en-US"/>
           </a:p>
@@ -657,7 +660,7 @@
           <a:p>
             <a:fld id="{07558649-2619-44F9-8F30-2D6466E57529}" type="datetimeFigureOut">
               <a:rPr lang="en-US" smtClean="0"/>
-              <a:t>3/26/2021</a:t>
+              <a:t>4/12/2021</a:t>
             </a:fld>
             <a:endParaRPr lang="en-US"/>
           </a:p>
@@ -825,7 +828,7 @@
           <a:p>
             <a:fld id="{07558649-2619-44F9-8F30-2D6466E57529}" type="datetimeFigureOut">
               <a:rPr lang="en-US" smtClean="0"/>
-              <a:t>3/26/2021</a:t>
+              <a:t>4/12/2021</a:t>
             </a:fld>
             <a:endParaRPr lang="en-US"/>
           </a:p>
@@ -1003,7 +1006,7 @@
           <a:p>
             <a:fld id="{07558649-2619-44F9-8F30-2D6466E57529}" type="datetimeFigureOut">
               <a:rPr lang="en-US" smtClean="0"/>
-              <a:t>3/26/2021</a:t>
+              <a:t>4/12/2021</a:t>
             </a:fld>
             <a:endParaRPr lang="en-US"/>
           </a:p>
@@ -1171,7 +1174,7 @@
           <a:p>
             <a:fld id="{07558649-2619-44F9-8F30-2D6466E57529}" type="datetimeFigureOut">
               <a:rPr lang="en-US" smtClean="0"/>
-              <a:t>3/26/2021</a:t>
+              <a:t>4/12/2021</a:t>
             </a:fld>
             <a:endParaRPr lang="en-US"/>
           </a:p>
@@ -1416,7 +1419,7 @@
           <a:p>
             <a:fld id="{07558649-2619-44F9-8F30-2D6466E57529}" type="datetimeFigureOut">
               <a:rPr lang="en-US" smtClean="0"/>
-              <a:t>3/26/2021</a:t>
+              <a:t>4/12/2021</a:t>
             </a:fld>
             <a:endParaRPr lang="en-US"/>
           </a:p>
@@ -1701,7 +1704,7 @@
           <a:p>
             <a:fld id="{07558649-2619-44F9-8F30-2D6466E57529}" type="datetimeFigureOut">
               <a:rPr lang="en-US" smtClean="0"/>
-              <a:t>3/26/2021</a:t>
+              <a:t>4/12/2021</a:t>
             </a:fld>
             <a:endParaRPr lang="en-US"/>
           </a:p>
@@ -2120,7 +2123,7 @@
           <a:p>
             <a:fld id="{07558649-2619-44F9-8F30-2D6466E57529}" type="datetimeFigureOut">
               <a:rPr lang="en-US" smtClean="0"/>
-              <a:t>3/26/2021</a:t>
+              <a:t>4/12/2021</a:t>
             </a:fld>
             <a:endParaRPr lang="en-US"/>
           </a:p>
@@ -2237,7 +2240,7 @@
           <a:p>
             <a:fld id="{07558649-2619-44F9-8F30-2D6466E57529}" type="datetimeFigureOut">
               <a:rPr lang="en-US" smtClean="0"/>
-              <a:t>3/26/2021</a:t>
+              <a:t>4/12/2021</a:t>
             </a:fld>
             <a:endParaRPr lang="en-US"/>
           </a:p>
@@ -2332,7 +2335,7 @@
           <a:p>
             <a:fld id="{07558649-2619-44F9-8F30-2D6466E57529}" type="datetimeFigureOut">
               <a:rPr lang="en-US" smtClean="0"/>
-              <a:t>3/26/2021</a:t>
+              <a:t>4/12/2021</a:t>
             </a:fld>
             <a:endParaRPr lang="en-US"/>
           </a:p>
@@ -2607,7 +2610,7 @@
           <a:p>
             <a:fld id="{07558649-2619-44F9-8F30-2D6466E57529}" type="datetimeFigureOut">
               <a:rPr lang="en-US" smtClean="0"/>
-              <a:t>3/26/2021</a:t>
+              <a:t>4/12/2021</a:t>
             </a:fld>
             <a:endParaRPr lang="en-US"/>
           </a:p>
@@ -2859,7 +2862,7 @@
           <a:p>
             <a:fld id="{07558649-2619-44F9-8F30-2D6466E57529}" type="datetimeFigureOut">
               <a:rPr lang="en-US" smtClean="0"/>
-              <a:t>3/26/2021</a:t>
+              <a:t>4/12/2021</a:t>
             </a:fld>
             <a:endParaRPr lang="en-US"/>
           </a:p>
@@ -3079,7 +3082,7 @@
           <a:p>
             <a:fld id="{07558649-2619-44F9-8F30-2D6466E57529}" type="datetimeFigureOut">
               <a:rPr lang="en-US" smtClean="0"/>
-              <a:t>3/26/2021</a:t>
+              <a:t>4/12/2021</a:t>
             </a:fld>
             <a:endParaRPr lang="en-US"/>
           </a:p>
@@ -3496,7 +3499,7 @@
               <a:rPr lang="es-MX" b="1" dirty="0">
                 <a:latin typeface="Century Gothic" panose="020B0502020202020204" pitchFamily="34" charset="0"/>
               </a:rPr>
-              <a:t>20/03/2021 – 26/03/2021</a:t>
+              <a:t>05/04/2021 – 09/04/2021</a:t>
             </a:r>
             <a:endParaRPr lang="es-MX" dirty="0">
               <a:latin typeface="Century Gothic" panose="020B0502020202020204" pitchFamily="34" charset="0"/>
@@ -3534,12 +3537,304 @@
           <a:chExt cx="0" cy="0"/>
         </a:xfrm>
       </p:grpSpPr>
+      <p:sp>
+        <p:nvSpPr>
+          <p:cNvPr id="8" name="Title 1"/>
+          <p:cNvSpPr txBox="1">
+            <a:spLocks/>
+          </p:cNvSpPr>
+          <p:nvPr/>
+        </p:nvSpPr>
+        <p:spPr>
+          <a:xfrm>
+            <a:off x="1087408" y="274638"/>
+            <a:ext cx="7229008" cy="622007"/>
+          </a:xfrm>
+          <a:prstGeom prst="rect">
+            <a:avLst/>
+          </a:prstGeom>
+        </p:spPr>
+        <p:txBody>
+          <a:bodyPr/>
+          <a:lstStyle>
+            <a:lvl1pPr algn="ctr" defTabSz="914400" rtl="0" eaLnBrk="1" latinLnBrk="0" hangingPunct="1">
+              <a:spcBef>
+                <a:spcPct val="0"/>
+              </a:spcBef>
+              <a:buNone/>
+              <a:defRPr sz="4400" kern="1200">
+                <a:solidFill>
+                  <a:schemeClr val="tx1"/>
+                </a:solidFill>
+                <a:latin typeface="+mj-lt"/>
+                <a:ea typeface="+mj-ea"/>
+                <a:cs typeface="+mj-cs"/>
+              </a:defRPr>
+            </a:lvl1pPr>
+          </a:lstStyle>
+          <a:p>
+            <a:pPr algn="l"/>
+            <a:r>
+              <a:rPr lang="es-ES" sz="2000" dirty="0">
+                <a:solidFill>
+                  <a:srgbClr val="3F1900"/>
+                </a:solidFill>
+              </a:rPr>
+              <a:t>QA: Inspección de Piel.</a:t>
+            </a:r>
+            <a:endParaRPr lang="en-US" sz="2000" dirty="0">
+              <a:solidFill>
+                <a:srgbClr val="3F1900"/>
+              </a:solidFill>
+            </a:endParaRPr>
+          </a:p>
+        </p:txBody>
+      </p:sp>
+      <p:sp>
+        <p:nvSpPr>
+          <p:cNvPr id="4" name="Content Placeholder 3"/>
+          <p:cNvSpPr txBox="1">
+            <a:spLocks/>
+          </p:cNvSpPr>
+          <p:nvPr/>
+        </p:nvSpPr>
+        <p:spPr>
+          <a:xfrm>
+            <a:off x="1331640" y="1196753"/>
+            <a:ext cx="7488832" cy="5137780"/>
+          </a:xfrm>
+          <a:prstGeom prst="rect">
+            <a:avLst/>
+          </a:prstGeom>
+        </p:spPr>
+        <p:txBody>
+          <a:bodyPr>
+            <a:normAutofit/>
+          </a:bodyPr>
+          <a:lstStyle>
+            <a:lvl1pPr marL="342900" indent="-342900" algn="l" defTabSz="914400" rtl="0" eaLnBrk="1" latinLnBrk="0" hangingPunct="1">
+              <a:spcBef>
+                <a:spcPct val="20000"/>
+              </a:spcBef>
+              <a:buFont typeface="Arial" panose="020B0604020202020204" pitchFamily="34" charset="0"/>
+              <a:buChar char="•"/>
+              <a:defRPr sz="3200" kern="1200">
+                <a:solidFill>
+                  <a:schemeClr val="tx1"/>
+                </a:solidFill>
+                <a:latin typeface="+mn-lt"/>
+                <a:ea typeface="+mn-ea"/>
+                <a:cs typeface="+mn-cs"/>
+              </a:defRPr>
+            </a:lvl1pPr>
+            <a:lvl2pPr marL="742950" indent="-285750" algn="l" defTabSz="914400" rtl="0" eaLnBrk="1" latinLnBrk="0" hangingPunct="1">
+              <a:spcBef>
+                <a:spcPct val="20000"/>
+              </a:spcBef>
+              <a:buFont typeface="Arial" panose="020B0604020202020204" pitchFamily="34" charset="0"/>
+              <a:buChar char="–"/>
+              <a:defRPr sz="2800" kern="1200">
+                <a:solidFill>
+                  <a:schemeClr val="tx1"/>
+                </a:solidFill>
+                <a:latin typeface="+mn-lt"/>
+                <a:ea typeface="+mn-ea"/>
+                <a:cs typeface="+mn-cs"/>
+              </a:defRPr>
+            </a:lvl2pPr>
+            <a:lvl3pPr marL="1143000" indent="-228600" algn="l" defTabSz="914400" rtl="0" eaLnBrk="1" latinLnBrk="0" hangingPunct="1">
+              <a:spcBef>
+                <a:spcPct val="20000"/>
+              </a:spcBef>
+              <a:buFont typeface="Arial" panose="020B0604020202020204" pitchFamily="34" charset="0"/>
+              <a:buChar char="•"/>
+              <a:defRPr sz="2400" kern="1200">
+                <a:solidFill>
+                  <a:schemeClr val="tx1"/>
+                </a:solidFill>
+                <a:latin typeface="+mn-lt"/>
+                <a:ea typeface="+mn-ea"/>
+                <a:cs typeface="+mn-cs"/>
+              </a:defRPr>
+            </a:lvl3pPr>
+            <a:lvl4pPr marL="1600200" indent="-228600" algn="l" defTabSz="914400" rtl="0" eaLnBrk="1" latinLnBrk="0" hangingPunct="1">
+              <a:spcBef>
+                <a:spcPct val="20000"/>
+              </a:spcBef>
+              <a:buFont typeface="Arial" panose="020B0604020202020204" pitchFamily="34" charset="0"/>
+              <a:buChar char="–"/>
+              <a:defRPr sz="2000" kern="1200">
+                <a:solidFill>
+                  <a:schemeClr val="tx1"/>
+                </a:solidFill>
+                <a:latin typeface="+mn-lt"/>
+                <a:ea typeface="+mn-ea"/>
+                <a:cs typeface="+mn-cs"/>
+              </a:defRPr>
+            </a:lvl4pPr>
+            <a:lvl5pPr marL="2057400" indent="-228600" algn="l" defTabSz="914400" rtl="0" eaLnBrk="1" latinLnBrk="0" hangingPunct="1">
+              <a:spcBef>
+                <a:spcPct val="20000"/>
+              </a:spcBef>
+              <a:buFont typeface="Arial" panose="020B0604020202020204" pitchFamily="34" charset="0"/>
+              <a:buChar char="»"/>
+              <a:defRPr sz="2000" kern="1200">
+                <a:solidFill>
+                  <a:schemeClr val="tx1"/>
+                </a:solidFill>
+                <a:latin typeface="+mn-lt"/>
+                <a:ea typeface="+mn-ea"/>
+                <a:cs typeface="+mn-cs"/>
+              </a:defRPr>
+            </a:lvl5pPr>
+            <a:lvl6pPr marL="2514600" indent="-228600" algn="l" defTabSz="914400" rtl="0" eaLnBrk="1" latinLnBrk="0" hangingPunct="1">
+              <a:spcBef>
+                <a:spcPct val="20000"/>
+              </a:spcBef>
+              <a:buFont typeface="Arial" panose="020B0604020202020204" pitchFamily="34" charset="0"/>
+              <a:buChar char="•"/>
+              <a:defRPr sz="2000" kern="1200">
+                <a:solidFill>
+                  <a:schemeClr val="tx1"/>
+                </a:solidFill>
+                <a:latin typeface="+mn-lt"/>
+                <a:ea typeface="+mn-ea"/>
+                <a:cs typeface="+mn-cs"/>
+              </a:defRPr>
+            </a:lvl6pPr>
+            <a:lvl7pPr marL="2971800" indent="-228600" algn="l" defTabSz="914400" rtl="0" eaLnBrk="1" latinLnBrk="0" hangingPunct="1">
+              <a:spcBef>
+                <a:spcPct val="20000"/>
+              </a:spcBef>
+              <a:buFont typeface="Arial" panose="020B0604020202020204" pitchFamily="34" charset="0"/>
+              <a:buChar char="•"/>
+              <a:defRPr sz="2000" kern="1200">
+                <a:solidFill>
+                  <a:schemeClr val="tx1"/>
+                </a:solidFill>
+                <a:latin typeface="+mn-lt"/>
+                <a:ea typeface="+mn-ea"/>
+                <a:cs typeface="+mn-cs"/>
+              </a:defRPr>
+            </a:lvl7pPr>
+            <a:lvl8pPr marL="3429000" indent="-228600" algn="l" defTabSz="914400" rtl="0" eaLnBrk="1" latinLnBrk="0" hangingPunct="1">
+              <a:spcBef>
+                <a:spcPct val="20000"/>
+              </a:spcBef>
+              <a:buFont typeface="Arial" panose="020B0604020202020204" pitchFamily="34" charset="0"/>
+              <a:buChar char="•"/>
+              <a:defRPr sz="2000" kern="1200">
+                <a:solidFill>
+                  <a:schemeClr val="tx1"/>
+                </a:solidFill>
+                <a:latin typeface="+mn-lt"/>
+                <a:ea typeface="+mn-ea"/>
+                <a:cs typeface="+mn-cs"/>
+              </a:defRPr>
+            </a:lvl8pPr>
+            <a:lvl9pPr marL="3886200" indent="-228600" algn="l" defTabSz="914400" rtl="0" eaLnBrk="1" latinLnBrk="0" hangingPunct="1">
+              <a:spcBef>
+                <a:spcPct val="20000"/>
+              </a:spcBef>
+              <a:buFont typeface="Arial" panose="020B0604020202020204" pitchFamily="34" charset="0"/>
+              <a:buChar char="•"/>
+              <a:defRPr sz="2000" kern="1200">
+                <a:solidFill>
+                  <a:schemeClr val="tx1"/>
+                </a:solidFill>
+                <a:latin typeface="+mn-lt"/>
+                <a:ea typeface="+mn-ea"/>
+                <a:cs typeface="+mn-cs"/>
+              </a:defRPr>
+            </a:lvl9pPr>
+          </a:lstStyle>
+          <a:p>
+            <a:pPr marL="0" indent="0" algn="just">
+              <a:buFont typeface="Arial" panose="020B0604020202020204" pitchFamily="34" charset="0"/>
+              <a:buNone/>
+            </a:pPr>
+            <a:endParaRPr lang="en-US" sz="2000" i="1"/>
+          </a:p>
+        </p:txBody>
+      </p:sp>
+      <p:sp>
+        <p:nvSpPr>
+          <p:cNvPr id="10" name="Rectangle 9"/>
+          <p:cNvSpPr/>
+          <p:nvPr/>
+        </p:nvSpPr>
+        <p:spPr>
+          <a:xfrm>
+            <a:off x="1331640" y="980728"/>
+            <a:ext cx="7632848" cy="276999"/>
+          </a:xfrm>
+          <a:prstGeom prst="rect">
+            <a:avLst/>
+          </a:prstGeom>
+        </p:spPr>
+        <p:txBody>
+          <a:bodyPr wrap="square">
+            <a:spAutoFit/>
+          </a:bodyPr>
+          <a:lstStyle/>
+          <a:p>
+            <a:pPr>
+              <a:buFont typeface="Arial" panose="020B0604020202020204" pitchFamily="34" charset="0"/>
+              <a:buChar char="•"/>
+            </a:pPr>
+            <a:r>
+              <a:rPr lang="es-ES" sz="1200" b="0" i="0" dirty="0">
+                <a:solidFill>
+                  <a:srgbClr val="222222"/>
+                </a:solidFill>
+                <a:effectLst/>
+                <a:latin typeface="Segoe UI" panose="020B0502040204020203" pitchFamily="34" charset="0"/>
+              </a:rPr>
+              <a:t> </a:t>
+            </a:r>
+            <a:r>
+              <a:rPr lang="es-ES" sz="1200" dirty="0">
+                <a:solidFill>
+                  <a:srgbClr val="222222"/>
+                </a:solidFill>
+                <a:latin typeface="Segoe UI" panose="020B0502040204020203" pitchFamily="34" charset="0"/>
+              </a:rPr>
+              <a:t>Se agrego Ficha que permitirá capturar los datos de </a:t>
+            </a:r>
+            <a:r>
+              <a:rPr lang="es-ES" sz="1200" b="1" dirty="0">
+                <a:solidFill>
+                  <a:srgbClr val="222222"/>
+                </a:solidFill>
+                <a:latin typeface="Segoe UI" panose="020B0502040204020203" pitchFamily="34" charset="0"/>
+              </a:rPr>
+              <a:t>Marcas Naturales </a:t>
+            </a:r>
+            <a:r>
+              <a:rPr lang="es-ES" sz="1200" dirty="0">
+                <a:solidFill>
+                  <a:srgbClr val="222222"/>
+                </a:solidFill>
+                <a:latin typeface="Segoe UI" panose="020B0502040204020203" pitchFamily="34" charset="0"/>
+              </a:rPr>
+              <a:t>de las pieles inspeccionadas.</a:t>
+            </a:r>
+            <a:endParaRPr lang="es-ES" sz="1200" b="0" i="0" dirty="0">
+              <a:solidFill>
+                <a:srgbClr val="222222"/>
+              </a:solidFill>
+              <a:effectLst/>
+              <a:latin typeface="Segoe UI" panose="020B0502040204020203" pitchFamily="34" charset="0"/>
+            </a:endParaRPr>
+          </a:p>
+        </p:txBody>
+      </p:sp>
       <p:pic>
         <p:nvPicPr>
-          <p:cNvPr id="6" name="Imagen 5" descr="Interfaz de usuario gráfica&#10;&#10;Descripción generada automáticamente con confianza media">
+          <p:cNvPr id="3" name="Imagen 2" descr="Interfaz de usuario gráfica, Aplicación&#10;&#10;Descripción generada automáticamente">
             <a:extLst>
               <a:ext uri="{FF2B5EF4-FFF2-40B4-BE49-F238E27FC236}">
-                <a16:creationId xmlns:a16="http://schemas.microsoft.com/office/drawing/2014/main" id="{B0E9D5FE-D1F5-4ED4-8124-FDD8B2BC2139}"/>
+                <a16:creationId xmlns:a16="http://schemas.microsoft.com/office/drawing/2014/main" id="{332BE704-B990-45F3-871B-01A8F5259E8F}"/>
               </a:ext>
             </a:extLst>
           </p:cNvPr>
@@ -3562,14 +3857,44 @@
         </p:blipFill>
         <p:spPr>
           <a:xfrm>
-            <a:off x="1187624" y="1498854"/>
-            <a:ext cx="7776864" cy="5242514"/>
+            <a:off x="1152128" y="1257728"/>
+            <a:ext cx="7956376" cy="5483640"/>
           </a:xfrm>
           <a:prstGeom prst="rect">
             <a:avLst/>
           </a:prstGeom>
         </p:spPr>
       </p:pic>
+    </p:spTree>
+    <p:extLst>
+      <p:ext uri="{BB962C8B-B14F-4D97-AF65-F5344CB8AC3E}">
+        <p14:creationId xmlns:p14="http://schemas.microsoft.com/office/powerpoint/2010/main" val="672802795"/>
+      </p:ext>
+    </p:extLst>
+  </p:cSld>
+  <p:clrMapOvr>
+    <a:masterClrMapping/>
+  </p:clrMapOvr>
+</p:sld>
+</file>
+
+<file path=ppt/slides/slide3.xml><?xml version="1.0" encoding="utf-8"?>
+<p:sld xmlns:a="http://schemas.openxmlformats.org/drawingml/2006/main" xmlns:r="http://schemas.openxmlformats.org/officeDocument/2006/relationships" xmlns:p="http://schemas.openxmlformats.org/presentationml/2006/main">
+  <p:cSld>
+    <p:spTree>
+      <p:nvGrpSpPr>
+        <p:cNvPr id="1" name=""/>
+        <p:cNvGrpSpPr/>
+        <p:nvPr/>
+      </p:nvGrpSpPr>
+      <p:grpSpPr>
+        <a:xfrm>
+          <a:off x="0" y="0"/>
+          <a:ext cx="0" cy="0"/>
+          <a:chOff x="0" y="0"/>
+          <a:chExt cx="0" cy="0"/>
+        </a:xfrm>
+      </p:grpSpPr>
       <p:sp>
         <p:nvSpPr>
           <p:cNvPr id="8" name="Title 1"/>
@@ -3799,6 +4124,509 @@
         <p:spPr>
           <a:xfrm>
             <a:off x="1331640" y="980728"/>
+            <a:ext cx="7632848" cy="646331"/>
+          </a:xfrm>
+          <a:prstGeom prst="rect">
+            <a:avLst/>
+          </a:prstGeom>
+        </p:spPr>
+        <p:txBody>
+          <a:bodyPr wrap="square">
+            <a:spAutoFit/>
+          </a:bodyPr>
+          <a:lstStyle/>
+          <a:p>
+            <a:pPr>
+              <a:buFont typeface="Arial" panose="020B0604020202020204" pitchFamily="34" charset="0"/>
+              <a:buChar char="•"/>
+            </a:pPr>
+            <a:r>
+              <a:rPr lang="es-ES" sz="1200" b="0" i="0" dirty="0">
+                <a:solidFill>
+                  <a:srgbClr val="222222"/>
+                </a:solidFill>
+                <a:effectLst/>
+                <a:latin typeface="Segoe UI" panose="020B0502040204020203" pitchFamily="34" charset="0"/>
+              </a:rPr>
+              <a:t> </a:t>
+            </a:r>
+            <a:r>
+              <a:rPr lang="es-ES" sz="1200" dirty="0">
+                <a:solidFill>
+                  <a:srgbClr val="222222"/>
+                </a:solidFill>
+                <a:latin typeface="Segoe UI" panose="020B0502040204020203" pitchFamily="34" charset="0"/>
+              </a:rPr>
+              <a:t>Se realizo lógica para el guardado de las diferentes inspecciones configuradas en </a:t>
+            </a:r>
+            <a:r>
+              <a:rPr lang="es-ES" sz="1200" b="1" dirty="0">
+                <a:solidFill>
+                  <a:srgbClr val="222222"/>
+                </a:solidFill>
+                <a:latin typeface="Segoe UI" panose="020B0502040204020203" pitchFamily="34" charset="0"/>
+              </a:rPr>
+              <a:t>SQL Server </a:t>
+            </a:r>
+            <a:r>
+              <a:rPr lang="es-ES" sz="1200" dirty="0">
+                <a:solidFill>
+                  <a:srgbClr val="222222"/>
+                </a:solidFill>
+                <a:latin typeface="Segoe UI" panose="020B0502040204020203" pitchFamily="34" charset="0"/>
+              </a:rPr>
+              <a:t>para esto se </a:t>
+            </a:r>
+            <a:r>
+              <a:rPr lang="es-ES" sz="1200" b="1" dirty="0">
+                <a:solidFill>
+                  <a:srgbClr val="222222"/>
+                </a:solidFill>
+                <a:latin typeface="Segoe UI" panose="020B0502040204020203" pitchFamily="34" charset="0"/>
+              </a:rPr>
+              <a:t>Crearon Tablas </a:t>
+            </a:r>
+            <a:r>
+              <a:rPr lang="es-ES" sz="1200" dirty="0">
+                <a:solidFill>
+                  <a:srgbClr val="222222"/>
+                </a:solidFill>
+                <a:latin typeface="Segoe UI" panose="020B0502040204020203" pitchFamily="34" charset="0"/>
+              </a:rPr>
+              <a:t>para almacenar la información de las inspecciones </a:t>
+            </a:r>
+            <a:r>
+              <a:rPr lang="es-ES" sz="1200" b="1" dirty="0">
+                <a:solidFill>
+                  <a:srgbClr val="222222"/>
+                </a:solidFill>
+                <a:latin typeface="Segoe UI" panose="020B0502040204020203" pitchFamily="34" charset="0"/>
+              </a:rPr>
+              <a:t>y Store Procedure </a:t>
+            </a:r>
+            <a:r>
+              <a:rPr lang="es-ES" sz="1200" dirty="0">
+                <a:solidFill>
+                  <a:srgbClr val="222222"/>
+                </a:solidFill>
+                <a:latin typeface="Segoe UI" panose="020B0502040204020203" pitchFamily="34" charset="0"/>
+              </a:rPr>
+              <a:t>que permitirán poblar las tablas de información.</a:t>
+            </a:r>
+            <a:endParaRPr lang="es-ES" sz="1200" b="0" i="0" dirty="0">
+              <a:solidFill>
+                <a:srgbClr val="222222"/>
+              </a:solidFill>
+              <a:effectLst/>
+              <a:latin typeface="Segoe UI" panose="020B0502040204020203" pitchFamily="34" charset="0"/>
+            </a:endParaRPr>
+          </a:p>
+        </p:txBody>
+      </p:sp>
+      <p:pic>
+        <p:nvPicPr>
+          <p:cNvPr id="5" name="Imagen 4">
+            <a:extLst>
+              <a:ext uri="{FF2B5EF4-FFF2-40B4-BE49-F238E27FC236}">
+                <a16:creationId xmlns:a16="http://schemas.microsoft.com/office/drawing/2014/main" id="{21624038-60C2-4DD1-A393-C890598ABB48}"/>
+              </a:ext>
+            </a:extLst>
+          </p:cNvPr>
+          <p:cNvPicPr>
+            <a:picLocks noChangeAspect="1"/>
+          </p:cNvPicPr>
+          <p:nvPr/>
+        </p:nvPicPr>
+        <p:blipFill rotWithShape="1">
+          <a:blip r:embed="rId2"/>
+          <a:srcRect l="50787" t="10801" r="13776" b="13601"/>
+          <a:stretch/>
+        </p:blipFill>
+        <p:spPr>
+          <a:xfrm>
+            <a:off x="1763688" y="1627059"/>
+            <a:ext cx="6552728" cy="5137780"/>
+          </a:xfrm>
+          <a:prstGeom prst="rect">
+            <a:avLst/>
+          </a:prstGeom>
+        </p:spPr>
+      </p:pic>
+    </p:spTree>
+    <p:extLst>
+      <p:ext uri="{BB962C8B-B14F-4D97-AF65-F5344CB8AC3E}">
+        <p14:creationId xmlns:p14="http://schemas.microsoft.com/office/powerpoint/2010/main" val="3700093572"/>
+      </p:ext>
+    </p:extLst>
+  </p:cSld>
+  <p:clrMapOvr>
+    <a:masterClrMapping/>
+  </p:clrMapOvr>
+</p:sld>
+</file>
+
+<file path=ppt/slides/slide4.xml><?xml version="1.0" encoding="utf-8"?>
+<p:sld xmlns:a="http://schemas.openxmlformats.org/drawingml/2006/main" xmlns:r="http://schemas.openxmlformats.org/officeDocument/2006/relationships" xmlns:p="http://schemas.openxmlformats.org/presentationml/2006/main">
+  <p:cSld>
+    <p:spTree>
+      <p:nvGrpSpPr>
+        <p:cNvPr id="1" name=""/>
+        <p:cNvGrpSpPr/>
+        <p:nvPr/>
+      </p:nvGrpSpPr>
+      <p:grpSpPr>
+        <a:xfrm>
+          <a:off x="0" y="0"/>
+          <a:ext cx="0" cy="0"/>
+          <a:chOff x="0" y="0"/>
+          <a:chExt cx="0" cy="0"/>
+        </a:xfrm>
+      </p:grpSpPr>
+      <p:sp>
+        <p:nvSpPr>
+          <p:cNvPr id="5" name="Title 1"/>
+          <p:cNvSpPr txBox="1">
+            <a:spLocks/>
+          </p:cNvSpPr>
+          <p:nvPr/>
+        </p:nvSpPr>
+        <p:spPr>
+          <a:xfrm>
+            <a:off x="1187624" y="2564904"/>
+            <a:ext cx="7772400" cy="1470025"/>
+          </a:xfrm>
+          <a:prstGeom prst="rect">
+            <a:avLst/>
+          </a:prstGeom>
+        </p:spPr>
+        <p:txBody>
+          <a:bodyPr vert="horz" lIns="91440" tIns="45720" rIns="91440" bIns="45720" rtlCol="0" anchor="ctr">
+            <a:normAutofit/>
+          </a:bodyPr>
+          <a:lstStyle>
+            <a:lvl1pPr algn="ctr" defTabSz="914400" rtl="0" eaLnBrk="1" latinLnBrk="0" hangingPunct="1">
+              <a:spcBef>
+                <a:spcPct val="0"/>
+              </a:spcBef>
+              <a:buNone/>
+              <a:defRPr sz="4400" kern="1200">
+                <a:solidFill>
+                  <a:schemeClr val="tx1"/>
+                </a:solidFill>
+                <a:latin typeface="+mj-lt"/>
+                <a:ea typeface="+mj-ea"/>
+                <a:cs typeface="+mj-cs"/>
+              </a:defRPr>
+            </a:lvl1pPr>
+          </a:lstStyle>
+          <a:p>
+            <a:r>
+              <a:rPr lang="es-MX" b="1" dirty="0">
+                <a:latin typeface="Century Gothic" panose="020B0502020202020204" pitchFamily="34" charset="0"/>
+              </a:rPr>
+              <a:t>20/03/2021 – 26/03/2021</a:t>
+            </a:r>
+            <a:endParaRPr lang="es-MX" dirty="0">
+              <a:latin typeface="Century Gothic" panose="020B0502020202020204" pitchFamily="34" charset="0"/>
+            </a:endParaRPr>
+          </a:p>
+        </p:txBody>
+      </p:sp>
+    </p:spTree>
+    <p:extLst>
+      <p:ext uri="{BB962C8B-B14F-4D97-AF65-F5344CB8AC3E}">
+        <p14:creationId xmlns:p14="http://schemas.microsoft.com/office/powerpoint/2010/main" val="3348773742"/>
+      </p:ext>
+    </p:extLst>
+  </p:cSld>
+  <p:clrMapOvr>
+    <a:masterClrMapping/>
+  </p:clrMapOvr>
+</p:sld>
+</file>
+
+<file path=ppt/slides/slide5.xml><?xml version="1.0" encoding="utf-8"?>
+<p:sld xmlns:a="http://schemas.openxmlformats.org/drawingml/2006/main" xmlns:r="http://schemas.openxmlformats.org/officeDocument/2006/relationships" xmlns:p="http://schemas.openxmlformats.org/presentationml/2006/main">
+  <p:cSld>
+    <p:spTree>
+      <p:nvGrpSpPr>
+        <p:cNvPr id="1" name=""/>
+        <p:cNvGrpSpPr/>
+        <p:nvPr/>
+      </p:nvGrpSpPr>
+      <p:grpSpPr>
+        <a:xfrm>
+          <a:off x="0" y="0"/>
+          <a:ext cx="0" cy="0"/>
+          <a:chOff x="0" y="0"/>
+          <a:chExt cx="0" cy="0"/>
+        </a:xfrm>
+      </p:grpSpPr>
+      <p:pic>
+        <p:nvPicPr>
+          <p:cNvPr id="7" name="Imagen 6" descr="Interfaz de usuario gráfica, Texto, Aplicación&#10;&#10;Descripción generada automáticamente con confianza media">
+            <a:extLst>
+              <a:ext uri="{FF2B5EF4-FFF2-40B4-BE49-F238E27FC236}">
+                <a16:creationId xmlns:a16="http://schemas.microsoft.com/office/drawing/2014/main" id="{569BD519-9317-4E15-816B-20B8B6A22A64}"/>
+              </a:ext>
+            </a:extLst>
+          </p:cNvPr>
+          <p:cNvPicPr>
+            <a:picLocks noChangeAspect="1"/>
+          </p:cNvPicPr>
+          <p:nvPr/>
+        </p:nvPicPr>
+        <p:blipFill>
+          <a:blip r:embed="rId2">
+            <a:extLst>
+              <a:ext uri="{28A0092B-C50C-407E-A947-70E740481C1C}">
+                <a14:useLocalDpi xmlns:a14="http://schemas.microsoft.com/office/drawing/2010/main" val="0"/>
+              </a:ext>
+            </a:extLst>
+          </a:blip>
+          <a:stretch>
+            <a:fillRect/>
+          </a:stretch>
+        </p:blipFill>
+        <p:spPr>
+          <a:xfrm>
+            <a:off x="1259632" y="1442393"/>
+            <a:ext cx="7776864" cy="5370983"/>
+          </a:xfrm>
+          <a:prstGeom prst="rect">
+            <a:avLst/>
+          </a:prstGeom>
+        </p:spPr>
+      </p:pic>
+      <p:sp>
+        <p:nvSpPr>
+          <p:cNvPr id="8" name="Title 1"/>
+          <p:cNvSpPr txBox="1">
+            <a:spLocks/>
+          </p:cNvSpPr>
+          <p:nvPr/>
+        </p:nvSpPr>
+        <p:spPr>
+          <a:xfrm>
+            <a:off x="1087408" y="274638"/>
+            <a:ext cx="7229008" cy="622007"/>
+          </a:xfrm>
+          <a:prstGeom prst="rect">
+            <a:avLst/>
+          </a:prstGeom>
+        </p:spPr>
+        <p:txBody>
+          <a:bodyPr/>
+          <a:lstStyle>
+            <a:lvl1pPr algn="ctr" defTabSz="914400" rtl="0" eaLnBrk="1" latinLnBrk="0" hangingPunct="1">
+              <a:spcBef>
+                <a:spcPct val="0"/>
+              </a:spcBef>
+              <a:buNone/>
+              <a:defRPr sz="4400" kern="1200">
+                <a:solidFill>
+                  <a:schemeClr val="tx1"/>
+                </a:solidFill>
+                <a:latin typeface="+mj-lt"/>
+                <a:ea typeface="+mj-ea"/>
+                <a:cs typeface="+mj-cs"/>
+              </a:defRPr>
+            </a:lvl1pPr>
+          </a:lstStyle>
+          <a:p>
+            <a:pPr algn="l"/>
+            <a:r>
+              <a:rPr lang="es-ES" sz="2000" dirty="0">
+                <a:solidFill>
+                  <a:srgbClr val="3F1900"/>
+                </a:solidFill>
+              </a:rPr>
+              <a:t>QA: Inspección de Piel.</a:t>
+            </a:r>
+            <a:endParaRPr lang="en-US" sz="2000" dirty="0">
+              <a:solidFill>
+                <a:srgbClr val="3F1900"/>
+              </a:solidFill>
+            </a:endParaRPr>
+          </a:p>
+        </p:txBody>
+      </p:sp>
+      <p:sp>
+        <p:nvSpPr>
+          <p:cNvPr id="4" name="Content Placeholder 3"/>
+          <p:cNvSpPr txBox="1">
+            <a:spLocks/>
+          </p:cNvSpPr>
+          <p:nvPr/>
+        </p:nvSpPr>
+        <p:spPr>
+          <a:xfrm>
+            <a:off x="1331640" y="1196753"/>
+            <a:ext cx="7488832" cy="5137780"/>
+          </a:xfrm>
+          <a:prstGeom prst="rect">
+            <a:avLst/>
+          </a:prstGeom>
+        </p:spPr>
+        <p:txBody>
+          <a:bodyPr>
+            <a:normAutofit/>
+          </a:bodyPr>
+          <a:lstStyle>
+            <a:lvl1pPr marL="342900" indent="-342900" algn="l" defTabSz="914400" rtl="0" eaLnBrk="1" latinLnBrk="0" hangingPunct="1">
+              <a:spcBef>
+                <a:spcPct val="20000"/>
+              </a:spcBef>
+              <a:buFont typeface="Arial" panose="020B0604020202020204" pitchFamily="34" charset="0"/>
+              <a:buChar char="•"/>
+              <a:defRPr sz="3200" kern="1200">
+                <a:solidFill>
+                  <a:schemeClr val="tx1"/>
+                </a:solidFill>
+                <a:latin typeface="+mn-lt"/>
+                <a:ea typeface="+mn-ea"/>
+                <a:cs typeface="+mn-cs"/>
+              </a:defRPr>
+            </a:lvl1pPr>
+            <a:lvl2pPr marL="742950" indent="-285750" algn="l" defTabSz="914400" rtl="0" eaLnBrk="1" latinLnBrk="0" hangingPunct="1">
+              <a:spcBef>
+                <a:spcPct val="20000"/>
+              </a:spcBef>
+              <a:buFont typeface="Arial" panose="020B0604020202020204" pitchFamily="34" charset="0"/>
+              <a:buChar char="–"/>
+              <a:defRPr sz="2800" kern="1200">
+                <a:solidFill>
+                  <a:schemeClr val="tx1"/>
+                </a:solidFill>
+                <a:latin typeface="+mn-lt"/>
+                <a:ea typeface="+mn-ea"/>
+                <a:cs typeface="+mn-cs"/>
+              </a:defRPr>
+            </a:lvl2pPr>
+            <a:lvl3pPr marL="1143000" indent="-228600" algn="l" defTabSz="914400" rtl="0" eaLnBrk="1" latinLnBrk="0" hangingPunct="1">
+              <a:spcBef>
+                <a:spcPct val="20000"/>
+              </a:spcBef>
+              <a:buFont typeface="Arial" panose="020B0604020202020204" pitchFamily="34" charset="0"/>
+              <a:buChar char="•"/>
+              <a:defRPr sz="2400" kern="1200">
+                <a:solidFill>
+                  <a:schemeClr val="tx1"/>
+                </a:solidFill>
+                <a:latin typeface="+mn-lt"/>
+                <a:ea typeface="+mn-ea"/>
+                <a:cs typeface="+mn-cs"/>
+              </a:defRPr>
+            </a:lvl3pPr>
+            <a:lvl4pPr marL="1600200" indent="-228600" algn="l" defTabSz="914400" rtl="0" eaLnBrk="1" latinLnBrk="0" hangingPunct="1">
+              <a:spcBef>
+                <a:spcPct val="20000"/>
+              </a:spcBef>
+              <a:buFont typeface="Arial" panose="020B0604020202020204" pitchFamily="34" charset="0"/>
+              <a:buChar char="–"/>
+              <a:defRPr sz="2000" kern="1200">
+                <a:solidFill>
+                  <a:schemeClr val="tx1"/>
+                </a:solidFill>
+                <a:latin typeface="+mn-lt"/>
+                <a:ea typeface="+mn-ea"/>
+                <a:cs typeface="+mn-cs"/>
+              </a:defRPr>
+            </a:lvl4pPr>
+            <a:lvl5pPr marL="2057400" indent="-228600" algn="l" defTabSz="914400" rtl="0" eaLnBrk="1" latinLnBrk="0" hangingPunct="1">
+              <a:spcBef>
+                <a:spcPct val="20000"/>
+              </a:spcBef>
+              <a:buFont typeface="Arial" panose="020B0604020202020204" pitchFamily="34" charset="0"/>
+              <a:buChar char="»"/>
+              <a:defRPr sz="2000" kern="1200">
+                <a:solidFill>
+                  <a:schemeClr val="tx1"/>
+                </a:solidFill>
+                <a:latin typeface="+mn-lt"/>
+                <a:ea typeface="+mn-ea"/>
+                <a:cs typeface="+mn-cs"/>
+              </a:defRPr>
+            </a:lvl5pPr>
+            <a:lvl6pPr marL="2514600" indent="-228600" algn="l" defTabSz="914400" rtl="0" eaLnBrk="1" latinLnBrk="0" hangingPunct="1">
+              <a:spcBef>
+                <a:spcPct val="20000"/>
+              </a:spcBef>
+              <a:buFont typeface="Arial" panose="020B0604020202020204" pitchFamily="34" charset="0"/>
+              <a:buChar char="•"/>
+              <a:defRPr sz="2000" kern="1200">
+                <a:solidFill>
+                  <a:schemeClr val="tx1"/>
+                </a:solidFill>
+                <a:latin typeface="+mn-lt"/>
+                <a:ea typeface="+mn-ea"/>
+                <a:cs typeface="+mn-cs"/>
+              </a:defRPr>
+            </a:lvl6pPr>
+            <a:lvl7pPr marL="2971800" indent="-228600" algn="l" defTabSz="914400" rtl="0" eaLnBrk="1" latinLnBrk="0" hangingPunct="1">
+              <a:spcBef>
+                <a:spcPct val="20000"/>
+              </a:spcBef>
+              <a:buFont typeface="Arial" panose="020B0604020202020204" pitchFamily="34" charset="0"/>
+              <a:buChar char="•"/>
+              <a:defRPr sz="2000" kern="1200">
+                <a:solidFill>
+                  <a:schemeClr val="tx1"/>
+                </a:solidFill>
+                <a:latin typeface="+mn-lt"/>
+                <a:ea typeface="+mn-ea"/>
+                <a:cs typeface="+mn-cs"/>
+              </a:defRPr>
+            </a:lvl7pPr>
+            <a:lvl8pPr marL="3429000" indent="-228600" algn="l" defTabSz="914400" rtl="0" eaLnBrk="1" latinLnBrk="0" hangingPunct="1">
+              <a:spcBef>
+                <a:spcPct val="20000"/>
+              </a:spcBef>
+              <a:buFont typeface="Arial" panose="020B0604020202020204" pitchFamily="34" charset="0"/>
+              <a:buChar char="•"/>
+              <a:defRPr sz="2000" kern="1200">
+                <a:solidFill>
+                  <a:schemeClr val="tx1"/>
+                </a:solidFill>
+                <a:latin typeface="+mn-lt"/>
+                <a:ea typeface="+mn-ea"/>
+                <a:cs typeface="+mn-cs"/>
+              </a:defRPr>
+            </a:lvl8pPr>
+            <a:lvl9pPr marL="3886200" indent="-228600" algn="l" defTabSz="914400" rtl="0" eaLnBrk="1" latinLnBrk="0" hangingPunct="1">
+              <a:spcBef>
+                <a:spcPct val="20000"/>
+              </a:spcBef>
+              <a:buFont typeface="Arial" panose="020B0604020202020204" pitchFamily="34" charset="0"/>
+              <a:buChar char="•"/>
+              <a:defRPr sz="2000" kern="1200">
+                <a:solidFill>
+                  <a:schemeClr val="tx1"/>
+                </a:solidFill>
+                <a:latin typeface="+mn-lt"/>
+                <a:ea typeface="+mn-ea"/>
+                <a:cs typeface="+mn-cs"/>
+              </a:defRPr>
+            </a:lvl9pPr>
+          </a:lstStyle>
+          <a:p>
+            <a:pPr marL="0" indent="0" algn="just">
+              <a:buFont typeface="Arial" panose="020B0604020202020204" pitchFamily="34" charset="0"/>
+              <a:buNone/>
+            </a:pPr>
+            <a:endParaRPr lang="en-US" sz="2000" i="1"/>
+          </a:p>
+        </p:txBody>
+      </p:sp>
+      <p:sp>
+        <p:nvSpPr>
+          <p:cNvPr id="10" name="Rectangle 9"/>
+          <p:cNvSpPr/>
+          <p:nvPr/>
+        </p:nvSpPr>
+        <p:spPr>
+          <a:xfrm>
+            <a:off x="1331640" y="980728"/>
             <a:ext cx="7632848" cy="461665"/>
           </a:xfrm>
           <a:prstGeom prst="rect">
@@ -3859,7 +4687,7 @@
                 </a:solidFill>
                 <a:latin typeface="Segoe UI" panose="020B0502040204020203" pitchFamily="34" charset="0"/>
               </a:rPr>
-              <a:t> Suavidad</a:t>
+              <a:t> Suavidad y  Marcas Naturales </a:t>
             </a:r>
             <a:r>
               <a:rPr lang="es-ES" sz="1200" dirty="0">
@@ -3868,7 +4696,7 @@
                 </a:solidFill>
                 <a:latin typeface="Segoe UI" panose="020B0502040204020203" pitchFamily="34" charset="0"/>
               </a:rPr>
-              <a:t> estos tipos son específicamente para inspeccionar Piel.</a:t>
+              <a:t>estos tipos son específicamente para inspeccionar Piel.</a:t>
             </a:r>
             <a:endParaRPr lang="es-ES" sz="1200" b="0" i="0" dirty="0">
               <a:solidFill>
@@ -3894,8 +4722,8 @@
         </p:nvSpPr>
         <p:spPr>
           <a:xfrm>
-            <a:off x="1691680" y="3717032"/>
-            <a:ext cx="792088" cy="216024"/>
+            <a:off x="1691680" y="3212976"/>
+            <a:ext cx="792088" cy="576064"/>
           </a:xfrm>
           <a:prstGeom prst="rect">
             <a:avLst/>
@@ -3945,7 +4773,7 @@
 </p:sld>
 </file>
 
-<file path=ppt/slides/slide3.xml><?xml version="1.0" encoding="utf-8"?>
+<file path=ppt/slides/slide6.xml><?xml version="1.0" encoding="utf-8"?>
 <p:sld xmlns:a="http://schemas.openxmlformats.org/drawingml/2006/main" xmlns:r="http://schemas.openxmlformats.org/officeDocument/2006/relationships" xmlns:p="http://schemas.openxmlformats.org/presentationml/2006/main">
   <p:cSld>
     <p:spTree>
@@ -4238,10 +5066,10 @@
       </p:sp>
       <p:pic>
         <p:nvPicPr>
-          <p:cNvPr id="3" name="Imagen 2" descr="Tabla&#10;&#10;Descripción generada automáticamente">
+          <p:cNvPr id="6" name="Imagen 5" descr="Interfaz de usuario gráfica, Texto, Aplicación&#10;&#10;Descripción generada automáticamente">
             <a:extLst>
               <a:ext uri="{FF2B5EF4-FFF2-40B4-BE49-F238E27FC236}">
-                <a16:creationId xmlns:a16="http://schemas.microsoft.com/office/drawing/2014/main" id="{E92678C9-02EC-43B2-A6F1-7BF9863ACE28}"/>
+                <a16:creationId xmlns:a16="http://schemas.microsoft.com/office/drawing/2014/main" id="{E0136657-DB66-44E5-9671-1376D8387D25}"/>
               </a:ext>
             </a:extLst>
           </p:cNvPr>
@@ -4250,7 +5078,7 @@
           </p:cNvPicPr>
           <p:nvPr/>
         </p:nvPicPr>
-        <p:blipFill rotWithShape="1">
+        <p:blipFill>
           <a:blip r:embed="rId2">
             <a:extLst>
               <a:ext uri="{28A0092B-C50C-407E-A947-70E740481C1C}">
@@ -4258,13 +5086,14 @@
               </a:ext>
             </a:extLst>
           </a:blip>
-          <a:srcRect b="1090"/>
-          <a:stretch/>
+          <a:stretch>
+            <a:fillRect/>
+          </a:stretch>
         </p:blipFill>
         <p:spPr>
           <a:xfrm>
-            <a:off x="1259632" y="1526477"/>
-            <a:ext cx="7704856" cy="5214892"/>
+            <a:off x="1187624" y="1526477"/>
+            <a:ext cx="7884368" cy="5286900"/>
           </a:xfrm>
           <a:prstGeom prst="rect">
             <a:avLst/>
@@ -4284,7 +5113,7 @@
 </p:sld>
 </file>
 
-<file path=ppt/slides/slide4.xml><?xml version="1.0" encoding="utf-8"?>
+<file path=ppt/slides/slide7.xml><?xml version="1.0" encoding="utf-8"?>
 <p:sld xmlns:a="http://schemas.openxmlformats.org/drawingml/2006/main" xmlns:r="http://schemas.openxmlformats.org/officeDocument/2006/relationships" xmlns:p="http://schemas.openxmlformats.org/presentationml/2006/main">
   <p:cSld>
     <p:spTree>
@@ -4563,7 +5392,25 @@
                 </a:solidFill>
                 <a:latin typeface="Segoe UI" panose="020B0502040204020203" pitchFamily="34" charset="0"/>
               </a:rPr>
-              <a:t>Se agrego Ficha que permitirá capturar los datos de la pieles inspeccionadas.</a:t>
+              <a:t>Se agrego Ficha que permitirá capturar los datos del </a:t>
+            </a:r>
+            <a:r>
+              <a:rPr lang="es-ES" sz="1200" b="1" dirty="0">
+                <a:solidFill>
+                  <a:srgbClr val="222222"/>
+                </a:solidFill>
+                <a:latin typeface="Segoe UI" panose="020B0502040204020203" pitchFamily="34" charset="0"/>
+              </a:rPr>
+              <a:t>Gross y Suavidad </a:t>
+            </a:r>
+            <a:r>
+              <a:rPr lang="es-ES" sz="1200" dirty="0">
+                <a:solidFill>
+                  <a:srgbClr val="222222"/>
+                </a:solidFill>
+                <a:latin typeface="Segoe UI" panose="020B0502040204020203" pitchFamily="34" charset="0"/>
+              </a:rPr>
+              <a:t>de las pieles inspeccionadas.</a:t>
             </a:r>
             <a:endParaRPr lang="es-ES" sz="1200" b="0" i="0" dirty="0">
               <a:solidFill>

</xml_diff>